<commit_message>
Enhanced design, added popup, TEAM1 branding update
</commit_message>
<xml_diff>
--- a/template.pptx
+++ b/template.pptx
@@ -6,6 +6,7 @@
   </p:sldMasterIdLst>
   <p:sldIdLst>
     <p:sldId id="256" r:id="rId7"/>
+    <p:sldId id="257" r:id="rId8"/>
   </p:sldIdLst>
   <p:sldSz cx="9144000" cy="6858000" type="screen4x3"/>
   <p:notesSz cx="6858000" cy="9144000"/>
@@ -3084,7 +3085,7 @@
     <p:bg>
       <p:bgPr>
         <a:solidFill>
-          <a:srgbClr val="EBF4FF"/>
+          <a:srgbClr val="193270"/>
         </a:solidFill>
         <a:effectLst/>
       </p:bgPr>
@@ -3098,57 +3099,14 @@
       <p:grpSpPr/>
       <p:sp>
         <p:nvSpPr>
-          <p:cNvPr id="2" name="Rectangle 1"/>
-          <p:cNvSpPr/>
+          <p:cNvPr id="2" name="TextBox 1"/>
+          <p:cNvSpPr txBox="1"/>
           <p:nvPr/>
         </p:nvSpPr>
         <p:spPr>
           <a:xfrm>
-            <a:off x="0" y="0"/>
-            <a:ext cx="9144000" cy="365760"/>
-          </a:xfrm>
-          <a:prstGeom prst="rect">
-            <a:avLst/>
-          </a:prstGeom>
-          <a:solidFill>
-            <a:srgbClr val="0066CC"/>
-          </a:solidFill>
-          <a:ln>
-            <a:noFill/>
-          </a:ln>
-        </p:spPr>
-        <p:style>
-          <a:lnRef idx="1">
-            <a:schemeClr val="accent1"/>
-          </a:lnRef>
-          <a:fillRef idx="3">
-            <a:schemeClr val="accent1"/>
-          </a:fillRef>
-          <a:effectRef idx="2">
-            <a:schemeClr val="accent1"/>
-          </a:effectRef>
-          <a:fontRef idx="minor">
-            <a:schemeClr val="lt1"/>
-          </a:fontRef>
-        </p:style>
-        <p:txBody>
-          <a:bodyPr rtlCol="0" anchor="ctr"/>
-          <a:lstStyle/>
-          <a:p>
-            <a:pPr algn="ctr"/>
-          </a:p>
-        </p:txBody>
-      </p:sp>
-      <p:sp>
-        <p:nvSpPr>
-          <p:cNvPr id="3" name="TextBox 2"/>
-          <p:cNvSpPr txBox="1"/>
-          <p:nvPr/>
-        </p:nvSpPr>
-        <p:spPr>
-          <a:xfrm>
-            <a:off x="914400" y="914400"/>
-            <a:ext cx="7315200" cy="1097280"/>
+            <a:off x="1371600" y="2286000"/>
+            <a:ext cx="7315200" cy="1828800"/>
           </a:xfrm>
           <a:prstGeom prst="rect">
             <a:avLst/>
@@ -3162,29 +3120,29 @@
           <a:lstStyle/>
           <a:p/>
           <a:p>
-            <a:pPr algn="l">
-              <a:defRPr sz="4400" b="1">
+            <a:pPr>
+              <a:defRPr b="1" sz="4800">
                 <a:solidFill>
-                  <a:srgbClr val="0A3C96"/>
+                  <a:srgbClr val="FFD700"/>
                 </a:solidFill>
               </a:defRPr>
             </a:pPr>
             <a:r>
-              <a:t>Your Slide Title</a:t>
-            </a:r>
-          </a:p>
-        </p:txBody>
-      </p:sp>
-      <p:sp>
-        <p:nvSpPr>
-          <p:cNvPr id="4" name="TextBox 3"/>
+              <a:t>AI Presentation Template</a:t>
+            </a:r>
+          </a:p>
+        </p:txBody>
+      </p:sp>
+      <p:sp>
+        <p:nvSpPr>
+          <p:cNvPr id="3" name="TextBox 2"/>
           <p:cNvSpPr txBox="1"/>
           <p:nvPr/>
         </p:nvSpPr>
         <p:spPr>
           <a:xfrm>
-            <a:off x="1097280" y="2286000"/>
-            <a:ext cx="6858000" cy="3657600"/>
+            <a:off x="1371600" y="3657600"/>
+            <a:ext cx="7315200" cy="1371600"/>
           </a:xfrm>
           <a:prstGeom prst="rect">
             <a:avLst/>
@@ -3198,39 +3156,76 @@
           <a:lstStyle/>
           <a:p/>
           <a:p>
-            <a:pPr algn="l">
-              <a:defRPr sz="2200">
+            <a:pPr>
+              <a:defRPr sz="2800">
                 <a:solidFill>
-                  <a:srgbClr val="282828"/>
+                  <a:srgbClr val="FFFFFF"/>
                 </a:solidFill>
               </a:defRPr>
             </a:pPr>
             <a:r>
-              <a:t>- Bullet point example 1</a:t>
-            </a:r>
-          </a:p>
-          <a:p>
-            <a:pPr algn="l">
-              <a:defRPr sz="2200">
+              <a:t>Generated using OpenAI + Unsplash</a:t>
+            </a:r>
+          </a:p>
+        </p:txBody>
+      </p:sp>
+    </p:spTree>
+  </p:cSld>
+  <p:clrMapOvr>
+    <a:masterClrMapping/>
+  </p:clrMapOvr>
+</p:sld>
+</file>
+
+<file path=ppt/slides/slide2.xml><?xml version="1.0" encoding="utf-8"?>
+<p:sld xmlns:a="http://schemas.openxmlformats.org/drawingml/2006/main" xmlns:p="http://schemas.openxmlformats.org/presentationml/2006/main" xmlns:r="http://schemas.openxmlformats.org/officeDocument/2006/relationships">
+  <p:cSld>
+    <p:bg>
+      <p:bgPr>
+        <a:solidFill>
+          <a:srgbClr val="E6F0FF"/>
+        </a:solidFill>
+        <a:effectLst/>
+      </p:bgPr>
+    </p:bg>
+    <p:spTree>
+      <p:nvGrpSpPr>
+        <p:cNvPr id="1" name=""/>
+        <p:cNvGrpSpPr/>
+        <p:nvPr/>
+      </p:nvGrpSpPr>
+      <p:grpSpPr/>
+      <p:sp>
+        <p:nvSpPr>
+          <p:cNvPr id="2" name="TextBox 1"/>
+          <p:cNvSpPr txBox="1"/>
+          <p:nvPr/>
+        </p:nvSpPr>
+        <p:spPr>
+          <a:xfrm>
+            <a:off x="914400" y="1097280"/>
+            <a:ext cx="7315200" cy="4572000"/>
+          </a:xfrm>
+          <a:prstGeom prst="rect">
+            <a:avLst/>
+          </a:prstGeom>
+          <a:noFill/>
+        </p:spPr>
+        <p:txBody>
+          <a:bodyPr wrap="square">
+            <a:spAutoFit/>
+          </a:bodyPr>
+          <a:lstStyle/>
+          <a:p>
+            <a:pPr>
+              <a:defRPr sz="2400">
                 <a:solidFill>
-                  <a:srgbClr val="282828"/>
+                  <a:srgbClr val="003366"/>
                 </a:solidFill>
               </a:defRPr>
             </a:pPr>
             <a:r>
-              <a:t>- Bullet point example 2</a:t>
-            </a:r>
-          </a:p>
-          <a:p>
-            <a:pPr algn="l">
-              <a:defRPr sz="2200">
-                <a:solidFill>
-                  <a:srgbClr val="282828"/>
-                </a:solidFill>
-              </a:defRPr>
-            </a:pPr>
-            <a:r>
-              <a:t>- Bullet point example 3</a:t>
+              <a:t>Content Slide Example</a:t>
             </a:r>
           </a:p>
         </p:txBody>

</xml_diff>